<commit_message>
ppt and overiew md
</commit_message>
<xml_diff>
--- a/template.pptx
+++ b/template.pptx
@@ -1357,7 +1357,7 @@
         </p:nvSpPr>
         <p:spPr>
           <a:xfrm>
-            <a:off x="381300" y="685800"/>
+            <a:off x="381000" y="685800"/>
             <a:ext cx="6096000" cy="3429000"/>
           </a:xfrm>
           <a:custGeom>
@@ -1479,7 +1479,7 @@
         </p:nvSpPr>
         <p:spPr>
           <a:xfrm>
-            <a:off x="381300" y="685800"/>
+            <a:off x="381000" y="685800"/>
             <a:ext cx="6096000" cy="3429000"/>
           </a:xfrm>
           <a:custGeom>
@@ -15117,7 +15117,7 @@
               <a:buNone/>
             </a:pPr>
             <a:r>
-              <a:rPr lang="en-GB" sz="1800" b="0" i="0" u="none" strike="noStrike" cap="none">
+              <a:rPr lang="en-GB" sz="1800" b="0" i="0" u="none" strike="noStrike" cap="none" dirty="0">
                 <a:solidFill>
                   <a:srgbClr val="000000"/>
                 </a:solidFill>
@@ -15126,9 +15126,9 @@
                 <a:cs typeface="Google Sans"/>
                 <a:sym typeface="Google Sans"/>
               </a:rPr>
-              <a:t>Snapshots of the MVP</a:t>
+              <a:t>Snapshots of the MVP:</a:t>
             </a:r>
-            <a:endParaRPr sz="1800" b="0" i="0" u="none" strike="noStrike" cap="none">
+            <a:endParaRPr sz="1800" b="0" i="0" u="none" strike="noStrike" cap="none" dirty="0">
               <a:solidFill>
                 <a:srgbClr val="000000"/>
               </a:solidFill>
@@ -15236,7 +15236,7 @@
               <a:buNone/>
             </a:pPr>
             <a:r>
-              <a:rPr lang="en-GB" sz="1800" b="0" i="0" u="none" strike="noStrike" cap="none">
+              <a:rPr lang="en-GB" sz="1800" b="0" i="0" u="none" strike="noStrike" cap="none" dirty="0">
                 <a:solidFill>
                   <a:srgbClr val="000000"/>
                 </a:solidFill>
@@ -15245,9 +15245,9 @@
                 <a:cs typeface="Google Sans"/>
                 <a:sym typeface="Google Sans"/>
               </a:rPr>
-              <a:t>Provide links to your:</a:t>
+              <a:t>Links:</a:t>
             </a:r>
-            <a:endParaRPr sz="1800" b="0" i="0" u="none" strike="noStrike" cap="none">
+            <a:endParaRPr sz="1800" b="0" i="0" u="none" strike="noStrike" cap="none" dirty="0">
               <a:solidFill>
                 <a:srgbClr val="000000"/>
               </a:solidFill>
@@ -15275,7 +15275,7 @@
               <a:buFont typeface="Arial"/>
               <a:buNone/>
             </a:pPr>
-            <a:endParaRPr sz="1800" b="0" i="0" u="none" strike="noStrike" cap="none">
+            <a:endParaRPr sz="1800" b="0" i="0" u="none" strike="noStrike" cap="none" dirty="0">
               <a:solidFill>
                 <a:srgbClr val="000000"/>
               </a:solidFill>
@@ -15304,7 +15304,7 @@
               <a:buAutoNum type="arabicPeriod"/>
             </a:pPr>
             <a:r>
-              <a:rPr lang="en-GB" sz="1800" b="0" i="0" u="none" strike="noStrike" cap="none">
+              <a:rPr lang="en-GB" sz="1800" b="0" i="0" u="none" strike="noStrike" cap="none" dirty="0">
                 <a:solidFill>
                   <a:srgbClr val="000000"/>
                 </a:solidFill>
@@ -15313,9 +15313,9 @@
                 <a:cs typeface="Google Sans"/>
                 <a:sym typeface="Google Sans"/>
               </a:rPr>
-              <a:t>GitHub Public Repository</a:t>
+              <a:t>GitHub Public Repository:</a:t>
             </a:r>
-            <a:endParaRPr sz="1800" b="0" i="0" u="none" strike="noStrike" cap="none">
+            <a:endParaRPr sz="1800" b="0" i="0" u="none" strike="noStrike" cap="none" dirty="0">
               <a:solidFill>
                 <a:srgbClr val="000000"/>
               </a:solidFill>
@@ -15336,100 +15336,20 @@
               <a:spcAft>
                 <a:spcPts val="0"/>
               </a:spcAft>
-              <a:buClr>
-                <a:srgbClr val="000000"/>
-              </a:buClr>
               <a:buSzPts val="1800"/>
               <a:buFont typeface="Google Sans"/>
               <a:buAutoNum type="arabicPeriod"/>
             </a:pPr>
             <a:r>
-              <a:rPr lang="en-GB" sz="1800" b="0" i="0" u="none" strike="noStrike" cap="none">
-                <a:solidFill>
-                  <a:srgbClr val="000000"/>
-                </a:solidFill>
+              <a:rPr lang="en-GB" sz="1800" dirty="0">
                 <a:latin typeface="Google Sans"/>
                 <a:ea typeface="Google Sans"/>
                 <a:cs typeface="Google Sans"/>
                 <a:sym typeface="Google Sans"/>
               </a:rPr>
-              <a:t>Demo Video Link (3 Minutes)</a:t>
+              <a:t>Working Prototype Link:</a:t>
             </a:r>
-            <a:endParaRPr sz="1800" b="0" i="0" u="none" strike="noStrike" cap="none">
-              <a:solidFill>
-                <a:srgbClr val="000000"/>
-              </a:solidFill>
-              <a:latin typeface="Google Sans"/>
-              <a:ea typeface="Google Sans"/>
-              <a:cs typeface="Google Sans"/>
-              <a:sym typeface="Google Sans"/>
-            </a:endParaRPr>
-          </a:p>
-          <a:p>
-            <a:pPr marL="457200" marR="0" lvl="0" indent="-342900" algn="l" rtl="0">
-              <a:lnSpc>
-                <a:spcPct val="100000"/>
-              </a:lnSpc>
-              <a:spcBef>
-                <a:spcPts val="0"/>
-              </a:spcBef>
-              <a:spcAft>
-                <a:spcPts val="0"/>
-              </a:spcAft>
-              <a:buClr>
-                <a:srgbClr val="000000"/>
-              </a:buClr>
-              <a:buSzPts val="1800"/>
-              <a:buFont typeface="Google Sans"/>
-              <a:buAutoNum type="arabicPeriod"/>
-            </a:pPr>
-            <a:r>
-              <a:rPr lang="en-GB" sz="1800" b="0" i="0" u="none" strike="noStrike" cap="none">
-                <a:solidFill>
-                  <a:srgbClr val="000000"/>
-                </a:solidFill>
-                <a:latin typeface="Google Sans"/>
-                <a:ea typeface="Google Sans"/>
-                <a:cs typeface="Google Sans"/>
-                <a:sym typeface="Google Sans"/>
-              </a:rPr>
-              <a:t>MVP Link</a:t>
-            </a:r>
-            <a:endParaRPr sz="1800" b="0" i="0" u="none" strike="noStrike" cap="none">
-              <a:solidFill>
-                <a:srgbClr val="000000"/>
-              </a:solidFill>
-              <a:latin typeface="Google Sans"/>
-              <a:ea typeface="Google Sans"/>
-              <a:cs typeface="Google Sans"/>
-              <a:sym typeface="Google Sans"/>
-            </a:endParaRPr>
-          </a:p>
-          <a:p>
-            <a:pPr marL="457200" marR="0" lvl="0" indent="-342900" algn="l" rtl="0">
-              <a:lnSpc>
-                <a:spcPct val="100000"/>
-              </a:lnSpc>
-              <a:spcBef>
-                <a:spcPts val="0"/>
-              </a:spcBef>
-              <a:spcAft>
-                <a:spcPts val="0"/>
-              </a:spcAft>
-              <a:buSzPts val="1800"/>
-              <a:buFont typeface="Google Sans"/>
-              <a:buAutoNum type="arabicPeriod"/>
-            </a:pPr>
-            <a:r>
-              <a:rPr lang="en-GB" sz="1800">
-                <a:latin typeface="Google Sans"/>
-                <a:ea typeface="Google Sans"/>
-                <a:cs typeface="Google Sans"/>
-                <a:sym typeface="Google Sans"/>
-              </a:rPr>
-              <a:t>Working Prototype Link</a:t>
-            </a:r>
-            <a:endParaRPr sz="1800">
+            <a:endParaRPr sz="1800" dirty="0">
               <a:latin typeface="Google Sans"/>
               <a:ea typeface="Google Sans"/>
               <a:cs typeface="Google Sans"/>

</xml_diff>